<commit_message>
deck: correct the net-of-cost slide (gross->NET) + confirm band 0.15. Slide 29 caveat 2 was factually wrong ('GROSS of costs, ~-5/oz, band 0.15 PENDING cost-aware confirmation') -> rewritten to 'CONFIRMED NET OF REALISTIC COST': re-verified under the maturity/vol cost model (M1/M2/M3 = 6/11/34 bps OI-calibrated + margin-funding term); band 0.15 stays best risk-adjusted under BOTH base and stressed cost (18.2/oz, std 35, mean/std 0.52, mean/CVaR5 0.41, 48/48 bound-PASS, 0 breaches); figures OI/vol proxies pending 2pm intraday. The 'MEAN IS NOISE / pick by std ordering' caveat kept. Future Work item 'realistic CME friction' marked DONE (remaining: intraday capture); manifest += commit 3073bf0, net_of_cost_frontier.csv, cost_model_realistic.json. 40 slides; backup platinum_hedge_management_deck_pre_netcost.pptx. Every figure recomputed from net_of_cost_frontier.csv.
Co-Authored-By: Claude Fable 5 <noreply@anthropic.com>
</commit_message>
<xml_diff>
--- a/artifacts/platinum_hedge_management_deck.pptx
+++ b/artifacts/platinum_hedge_management_deck.pptx
@@ -19485,7 +19485,7 @@
                 </a:solidFill>
                 <a:latin typeface="Calibri"/>
               </a:rPr>
-              <a:t>artifacts/walk_forward/corridor_band_frontier.csv (both worlds, bands 0.15–0.60) · garch48_corridor_rolls.csv. Loss-tail analysis: commit 5e61ae5. CVaR5 = mean of the worst 3 months; worst month = min realized $/oz.</a:t>
+              <a:t>artifacts/walk_forward/corridor_band_frontier.csv (both worlds, bands 0.15–0.60) · garch48_corridor_rolls.csv. Loss-tail analysis: commit 5e61ae5. CVaR5 = mean of the worst 3 months; worst month = min realized $/oz.  Net of realistic cost: net_of_cost_frontier.csv · cost_model_realistic.json (commit 3073bf0).</a:t>
             </a:r>
           </a:p>
         </p:txBody>
@@ -20666,11 +20666,11 @@
             <a:r>
               <a:rPr sz="1200" b="1">
                 <a:solidFill>
-                  <a:srgbClr val="B03A2E"/>
-                </a:solidFill>
-                <a:latin typeface="Calibri"/>
-              </a:rPr>
-              <a:t>CAVEAT 2  ·  GROSS OF COSTS</a:t>
+                  <a:srgbClr val="1F77B4"/>
+                </a:solidFill>
+                <a:latin typeface="Calibri"/>
+              </a:rPr>
+              <a:t>CONFIRMED  ·  NET OF REALISTIC COST</a:t>
             </a:r>
           </a:p>
           <a:p>
@@ -20681,7 +20681,7 @@
                 </a:solidFill>
                 <a:latin typeface="Calibri"/>
               </a:rPr>
-              <a:t>All rows are GROSS. Churn (≈255 contracts) is unchanged across bands, so ≈10 bps ≈ −5/oz off every row uniformly. The net-of-cost ranking has NOT been re-verified — 0.15 is a RECOMMENDATION PENDING a cost-aware confirmation, not a shipped decision.</a:t>
+              <a:t>Re-verified net of a maturity/vol cost model — M1/M2/M3 = 6/11/34 bps from open interest, plus a margin-funding term. Under BOTH a base and a stressed cost case, band 0.15 stays best risk-adjusted — 18.2 $/oz, std 35, mean/std 0.52, mean/CVaR5 0.41, 48/48 bound-PASS, 0 breaches. Figures are OI/vol proxies pending 2 pm-synced intraday calibration.</a:t>
             </a:r>
           </a:p>
         </p:txBody>
@@ -23818,7 +23818,7 @@
                           </a:solidFill>
                           <a:latin typeface="Calibri"/>
                         </a:rPr>
-                        <a:t>Realistic CME friction</a:t>
+                        <a:t>Intraday-calibrated CME friction</a:t>
                       </a:r>
                     </a:p>
                   </a:txBody>
@@ -23841,7 +23841,7 @@
                           </a:solidFill>
                           <a:latin typeface="Calibri"/>
                         </a:rPr>
-                        <a:t>Replace the flat 10 bps bid-offer with calibrated exchange fee + market-impact data, then re-verify the net-of-cost band ranking before adopting the tighter 0.15 operating point.</a:t>
+                        <a:t>DONE — net-of-cost band ranking re-verified under a realistic maturity/vol cost model (M1/M2/M3 = 6/11/34 bps, OI-calibrated); band 0.15 holds under base and stressed cost. Remaining: 2 pm-synced intraday spread capture, revisit as it accrues.</a:t>
                       </a:r>
                     </a:p>
                   </a:txBody>
@@ -27629,7 +27629,7 @@
                           </a:solidFill>
                           <a:latin typeface="Calibri"/>
                         </a:rPr>
-                        <a:t>c87284d · f8c067b · 5460692 · 74ef6de · c52411d · 11ef68d · 5e61ae5</a:t>
+                        <a:t>c87284d · f8c067b · 5460692 · 74ef6de · c52411d · 11ef68d · 5e61ae5 · 3073bf0</a:t>
                       </a:r>
                     </a:p>
                   </a:txBody>
@@ -27798,7 +27798,7 @@
                           </a:solidFill>
                           <a:latin typeface="Calibri"/>
                         </a:rPr>
-                        <a:t>GARCH corridor + band frontier</a:t>
+                        <a:t>Band frontier + net-of-cost</a:t>
                       </a:r>
                     </a:p>
                   </a:txBody>
@@ -27821,7 +27821,7 @@
                           </a:solidFill>
                           <a:latin typeface="Calibri"/>
                         </a:rPr>
-                        <a:t>artifacts/walk_forward/garch48_corridor_rolls.csv · corridor_band_frontier.csv  (bands 0.15–0.60, both worlds)</a:t>
+                        <a:t>garch48_corridor_rolls.csv · corridor_band_frontier.csv · net_of_cost_frontier.csv · cost_model_realistic.json  (bands 0.15–0.60; base / high cost)</a:t>
                       </a:r>
                     </a:p>
                   </a:txBody>

</xml_diff>

<commit_message>
deck: under-hedge fork DECIDED (user) - Option A fence-as-mandate adopted, roll-time band 0.15 becomes the mandate; Option B (min-variance objective) demoted to research track. Slides 31/36: 'open management decision' -> DECIDED, with the remaining gate stated - the operating point locks after the intraday capture near the 14:00 LBMA publishing window establishes whether the basis drops at the fixing (shipping config stays band 0.60 interim until then).
Co-Authored-By: Claude Fable 5 <noreply@anthropic.com>
</commit_message>
<xml_diff>
--- a/artifacts/platinum_hedge_management_deck.pptx
+++ b/artifacts/platinum_hedge_management_deck.pptx
@@ -21328,16 +21328,7 @@
                 </a:solidFill>
                 <a:latin typeface="Calibri"/>
               </a:rPr>
-              <a:t>OPEN MANAGEMENT DECISION — not yet made:  </a:t>
-            </a:r>
-            <a:r>
-              <a:rPr sz="1150">
-                <a:solidFill>
-                  <a:srgbClr val="2B3A42"/>
-                </a:solidFill>
-                <a:latin typeface="Calibri"/>
-              </a:rPr>
-              <a:t>aversion within the current utility is exhausted (≤ +0.06), so only a structural change — Option A or B — closes the tail. The driftless-fix world is P&amp;L-neutral, so no walk-forward number restates.</a:t>
+              <a:t>DECISION — Option A ADOPTED: the roll-time band 0.15 becomes the mandate. Aversion within the current utility is exhausted (≤ +0.06), so only a structural change closes the tail; Option B (min-variance objective) stays a research track. Remaining data check before the operating point is locked: intraday marks near the 14:00 LBMA publishing window, to establish whether the basis drops at the fixing.</a:t>
             </a:r>
           </a:p>
         </p:txBody>
@@ -24039,7 +24030,7 @@
                 </a:solidFill>
                 <a:latin typeface="Calibri"/>
               </a:rPr>
-              <a:t>The corridor ships as a risk control today; the hard guard remains a sign-off item. Fence-as-mandate (0.15) vs a min-variance objective (slide 31) is an open management decision.</a:t>
+              <a:t>The corridor ships as a risk control today; the hard guard remains a sign-off item. DECIDED: fence-as-mandate at band 0.15 (slide 31); final lock pending the 14:00-LBMA intraday basis check.</a:t>
             </a:r>
           </a:p>
         </p:txBody>

</xml_diff>